<commit_message>
dashboard: 2026-09-14 21:07 刷新
</commit_message>
<xml_diff>
--- a/media/figstudio/fig01_evidence_map/fig01_evidence_synthesis_map_editable.pptx
+++ b/media/figstudio/fig01_evidence_map/fig01_evidence_synthesis_map_editable.pptx
@@ -6994,7 +6994,7 @@
                 <a:ea typeface="Noto Sans CJK SC"/>
                 <a:cs typeface="Noto Sans CJK SC"/>
               </a:rPr>
-              <a:t>热史</a:t>
+              <a:t>热历史</a:t>
             </a:r>
           </a:p>
         </p:txBody>
@@ -8730,7 +8730,7 @@
                 <a:ea typeface="Noto Sans CJK SC"/>
                 <a:cs typeface="Noto Sans CJK SC"/>
               </a:rPr>
-              <a:t>谱系内相图与结构比较</a:t>
+              <a:t>系列内相图与结构比较</a:t>
             </a:r>
           </a:p>
         </p:txBody>

</xml_diff>